<commit_message>
added names to ppt
</commit_message>
<xml_diff>
--- a/LabBook_40.pptx
+++ b/LabBook_40.pptx
@@ -3194,30 +3194,26 @@
           <a:lstStyle/>
           <a:p>
             <a:pPr marL="12700">
-              <a:lnSpc>
-                <a:spcPct val="100000"/>
-              </a:lnSpc>
               <a:spcBef>
                 <a:spcPts val="100"/>
               </a:spcBef>
             </a:pPr>
             <a:r>
-              <a:rPr lang="es-ES" spc="165" dirty="0" err="1">
+              <a:rPr lang="es-ES" spc="165">
                 <a:latin typeface="Arial"/>
                 <a:cs typeface="Arial"/>
               </a:rPr>
-              <a:t>Student</a:t>
-            </a:r>
-            <a:r>
-              <a:rPr lang="es-ES" spc="165" dirty="0">
-                <a:latin typeface="Arial"/>
-                <a:cs typeface="Arial"/>
-              </a:rPr>
-              <a:t>: </a:t>
-            </a:r>
-            <a:endParaRPr sz="1800" dirty="0">
-              <a:latin typeface="Arial"/>
-              <a:cs typeface="Arial"/>
+              <a:t>Student: Giorgio Andreoli, Candela Molinos Rodríguez-Murcia</a:t>
+            </a:r>
+            <a:endParaRPr lang="es-ES" sz="2100" dirty="0">
+              <a:solidFill>
+                <a:srgbClr val="242424"/>
+              </a:solidFill>
+              <a:highlight>
+                <a:srgbClr val="FFFFFF"/>
+              </a:highlight>
+              <a:latin typeface="Segoe UI"/>
+              <a:cs typeface="Segoe UI"/>
             </a:endParaRPr>
           </a:p>
         </p:txBody>

</xml_diff>